<commit_message>
fixing typos and unclarities in presentations
</commit_message>
<xml_diff>
--- a/docs/day-1-session-5-model-selection.pptx
+++ b/docs/day-1-session-5-model-selection.pptx
@@ -185,7 +185,7 @@
   <pc:docChgLst>
     <pc:chgData name="Jolan Heyse" userId="960fa660-ab54-4cd3-b9d2-159a5d7ebdb8" providerId="ADAL" clId="{63D4EA39-128F-5223-85F2-0699DF93DF01}"/>
     <pc:docChg chg="undo custSel addSld delSld modSld sldOrd">
-      <pc:chgData name="Jolan Heyse" userId="960fa660-ab54-4cd3-b9d2-159a5d7ebdb8" providerId="ADAL" clId="{63D4EA39-128F-5223-85F2-0699DF93DF01}" dt="2026-03-31T11:37:30.460" v="786" actId="113"/>
+      <pc:chgData name="Jolan Heyse" userId="960fa660-ab54-4cd3-b9d2-159a5d7ebdb8" providerId="ADAL" clId="{63D4EA39-128F-5223-85F2-0699DF93DF01}" dt="2026-04-03T08:31:41.269" v="794" actId="20577"/>
       <pc:docMkLst>
         <pc:docMk/>
       </pc:docMkLst>
@@ -294,7 +294,7 @@
         </pc:spChg>
       </pc:sldChg>
       <pc:sldChg chg="modSp mod">
-        <pc:chgData name="Jolan Heyse" userId="960fa660-ab54-4cd3-b9d2-159a5d7ebdb8" providerId="ADAL" clId="{63D4EA39-128F-5223-85F2-0699DF93DF01}" dt="2026-03-31T11:25:16.041" v="638" actId="14100"/>
+        <pc:chgData name="Jolan Heyse" userId="960fa660-ab54-4cd3-b9d2-159a5d7ebdb8" providerId="ADAL" clId="{63D4EA39-128F-5223-85F2-0699DF93DF01}" dt="2026-04-03T08:31:41.269" v="794" actId="20577"/>
         <pc:sldMkLst>
           <pc:docMk/>
           <pc:sldMk cId="4119166068" sldId="613"/>
@@ -305,6 +305,14 @@
             <pc:docMk/>
             <pc:sldMk cId="4119166068" sldId="613"/>
             <ac:spMk id="6" creationId="{9CF2D2F7-D79D-318E-3484-8E876E1D86BE}"/>
+          </ac:spMkLst>
+        </pc:spChg>
+        <pc:spChg chg="mod">
+          <ac:chgData name="Jolan Heyse" userId="960fa660-ab54-4cd3-b9d2-159a5d7ebdb8" providerId="ADAL" clId="{63D4EA39-128F-5223-85F2-0699DF93DF01}" dt="2026-04-03T08:31:41.269" v="794" actId="20577"/>
+          <ac:spMkLst>
+            <pc:docMk/>
+            <pc:sldMk cId="4119166068" sldId="613"/>
+            <ac:spMk id="11" creationId="{708D2119-D996-4C38-0F4C-A43AB914D65B}"/>
           </ac:spMkLst>
         </pc:spChg>
         <pc:spChg chg="mod">
@@ -684,7 +692,7 @@
           <a:p>
             <a:fld id="{89BD6ADD-B21C-E948-AA04-DCFC50B51270}" type="datetimeFigureOut">
               <a:rPr lang="en-BE" smtClean="0"/>
-              <a:t>3/31/26</a:t>
+              <a:t>4/3/26</a:t>
             </a:fld>
             <a:endParaRPr lang="en-BE"/>
           </a:p>
@@ -869,7 +877,7 @@
           <a:p>
             <a:fld id="{F9571814-10B7-DF4E-B6E5-F469B8DD27A5}" type="datetimeFigureOut">
               <a:rPr lang="en-BE" smtClean="0"/>
-              <a:t>3/31/26</a:t>
+              <a:t>4/3/26</a:t>
             </a:fld>
             <a:endParaRPr lang="en-BE"/>
           </a:p>
@@ -47336,7 +47344,7 @@
           <p:spPr>
             <a:xfrm>
               <a:off x="9375096" y="4120138"/>
-              <a:ext cx="843225" cy="319398"/>
+              <a:ext cx="896827" cy="319398"/>
             </a:xfrm>
             <a:prstGeom prst="rect">
               <a:avLst/>
@@ -47381,7 +47389,7 @@
                   <a:ea typeface="+mn-ea"/>
                   <a:cs typeface="+mn-cs"/>
                 </a:rPr>
-                <a:t>positive</a:t>
+                <a:t>negative</a:t>
               </a:r>
             </a:p>
           </p:txBody>
@@ -55010,15 +55018,6 @@
 </file>
 
 <file path=customXml/item2.xml><?xml version="1.0" encoding="utf-8"?>
-<?mso-contentType ?>
-<FormTemplates xmlns="http://schemas.microsoft.com/sharepoint/v3/contenttype/forms">
-  <Display>DocumentLibraryForm</Display>
-  <Edit>DocumentLibraryForm</Edit>
-  <New>DocumentLibraryForm</New>
-</FormTemplates>
-</file>
-
-<file path=customXml/item3.xml><?xml version="1.0" encoding="utf-8"?>
 <ct:contentTypeSchema xmlns:ct="http://schemas.microsoft.com/office/2006/metadata/contentType" xmlns:ma="http://schemas.microsoft.com/office/2006/metadata/properties/metaAttributes" ct:_="" ma:_="" ma:contentTypeName="Document" ma:contentTypeID="0x010100EC511F386D030F4B8CF7456444C35157" ma:contentTypeVersion="14" ma:contentTypeDescription="Create a new document." ma:contentTypeScope="" ma:versionID="c9daff749ba6224a5c6dc27404156dd1">
   <xsd:schema xmlns:xsd="http://www.w3.org/2001/XMLSchema" xmlns:xs="http://www.w3.org/2001/XMLSchema" xmlns:p="http://schemas.microsoft.com/office/2006/metadata/properties" xmlns:ns2="4f1e66cd-5088-4f6e-aae8-bee95240a7ff" xmlns:ns3="06909bdf-adb9-4f3a-bbc9-bbcd31ddd6aa" targetNamespace="http://schemas.microsoft.com/office/2006/metadata/properties" ma:root="true" ma:fieldsID="12faaec27776cdd80a2a2207652cd290" ns2:_="" ns3:_="">
     <xsd:import namespace="4f1e66cd-5088-4f6e-aae8-bee95240a7ff"/>
@@ -55231,32 +55230,33 @@
 </ct:contentTypeSchema>
 </file>
 
+<file path=customXml/item3.xml><?xml version="1.0" encoding="utf-8"?>
+<?mso-contentType ?>
+<FormTemplates xmlns="http://schemas.microsoft.com/sharepoint/v3/contenttype/forms">
+  <Display>DocumentLibraryForm</Display>
+  <Edit>DocumentLibraryForm</Edit>
+  <New>DocumentLibraryForm</New>
+</FormTemplates>
+</file>
+
 <file path=customXml/itemProps1.xml><?xml version="1.0" encoding="utf-8"?>
 <ds:datastoreItem xmlns:ds="http://schemas.openxmlformats.org/officeDocument/2006/customXml" ds:itemID="{8AED3BBA-80BA-4FEB-B95D-8FDEE8AE801F}">
   <ds:schemaRefs>
+    <ds:schemaRef ds:uri="http://schemas.openxmlformats.org/package/2006/metadata/core-properties"/>
+    <ds:schemaRef ds:uri="http://purl.org/dc/elements/1.1/"/>
+    <ds:schemaRef ds:uri="06909bdf-adb9-4f3a-bbc9-bbcd31ddd6aa"/>
+    <ds:schemaRef ds:uri="http://www.w3.org/XML/1998/namespace"/>
+    <ds:schemaRef ds:uri="http://schemas.microsoft.com/office/2006/documentManagement/types"/>
+    <ds:schemaRef ds:uri="4f1e66cd-5088-4f6e-aae8-bee95240a7ff"/>
+    <ds:schemaRef ds:uri="http://schemas.microsoft.com/office/2006/metadata/properties"/>
     <ds:schemaRef ds:uri="http://schemas.microsoft.com/office/infopath/2007/PartnerControls"/>
-    <ds:schemaRef ds:uri="http://schemas.microsoft.com/office/2006/documentManagement/types"/>
-    <ds:schemaRef ds:uri="http://schemas.microsoft.com/office/2006/metadata/properties"/>
-    <ds:schemaRef ds:uri="http://www.w3.org/XML/1998/namespace"/>
+    <ds:schemaRef ds:uri="http://purl.org/dc/dcmitype/"/>
     <ds:schemaRef ds:uri="http://purl.org/dc/terms/"/>
-    <ds:schemaRef ds:uri="http://purl.org/dc/dcmitype/"/>
-    <ds:schemaRef ds:uri="4f1e66cd-5088-4f6e-aae8-bee95240a7ff"/>
-    <ds:schemaRef ds:uri="http://purl.org/dc/elements/1.1/"/>
-    <ds:schemaRef ds:uri="http://schemas.openxmlformats.org/package/2006/metadata/core-properties"/>
-    <ds:schemaRef ds:uri="06909bdf-adb9-4f3a-bbc9-bbcd31ddd6aa"/>
   </ds:schemaRefs>
 </ds:datastoreItem>
 </file>
 
 <file path=customXml/itemProps2.xml><?xml version="1.0" encoding="utf-8"?>
-<ds:datastoreItem xmlns:ds="http://schemas.openxmlformats.org/officeDocument/2006/customXml" ds:itemID="{89053B1D-5265-4FE1-99E2-844AC6646F4D}">
-  <ds:schemaRefs>
-    <ds:schemaRef ds:uri="http://schemas.microsoft.com/sharepoint/v3/contenttype/forms"/>
-  </ds:schemaRefs>
-</ds:datastoreItem>
-</file>
-
-<file path=customXml/itemProps3.xml><?xml version="1.0" encoding="utf-8"?>
 <ds:datastoreItem xmlns:ds="http://schemas.openxmlformats.org/officeDocument/2006/customXml" ds:itemID="{F50C8EC5-BEA5-4279-A1E6-1928F07D974B}">
   <ds:schemaRefs>
     <ds:schemaRef ds:uri="http://schemas.microsoft.com/office/2006/metadata/contentType"/>
@@ -55273,4 +55273,12 @@
     <ds:schemaRef ds:uri="http://schemas.microsoft.com/internal/obd"/>
   </ds:schemaRefs>
 </ds:datastoreItem>
+</file>
+
+<file path=customXml/itemProps3.xml><?xml version="1.0" encoding="utf-8"?>
+<ds:datastoreItem xmlns:ds="http://schemas.openxmlformats.org/officeDocument/2006/customXml" ds:itemID="{89053B1D-5265-4FE1-99E2-844AC6646F4D}">
+  <ds:schemaRefs>
+    <ds:schemaRef ds:uri="http://schemas.microsoft.com/sharepoint/v3/contenttype/forms"/>
+  </ds:schemaRefs>
+</ds:datastoreItem>
 </file>
</xml_diff>